<commit_message>
Choose the threshold for false alarms; add the operating-curve tool
--threshold-objective false-alarms picks, on the validation participants,
the most recall within --max-false-alarms per hour of non-eating;
--threshold-objective f0.5 weights precision twice recall. Both are in
the run name. operating_curve.py sweeps the threshold over saved
predictions of finished runs, so the trade-off can be seen without
retraining. Adds a false-positive slide to the lab-meeting deck.

Co-Authored-By: Claude Opus 5.5 <noreply@anthropic.com>
Claude-Session: https://claude.ai/code/session_017rMsJrfJb6LTfE8bFvgHeu
</commit_message>
<xml_diff>
--- a/docs/presentation/lab_meeting_new_slides.pptx
+++ b/docs/presentation/lab_meeting_new_slides.pptx
@@ -12,9 +12,10 @@
     <p:sldId id="260" r:id="rId6"/>
     <p:sldId id="261" r:id="rId7"/>
     <p:sldId id="262" r:id="rId8"/>
+    <p:sldId id="263" r:id="rId9"/>
   </p:sldIdLst>
   <p:notesMasterIdLst>
-    <p:notesMasterId r:id="rId9"/>
+    <p:notesMasterId r:id="rId10"/>
   </p:notesMasterIdLst>
   <p:sldSz cx="9144000" cy="5143500"/>
   <p:notesSz cx="5143500" cy="9144000"/>
@@ -1708,7 +1709,7 @@
           <a:p>
             <a:r>
               <a:rPr lang="en-US" dirty="0"/>
-              <a:t>The folds are fixed on purpose, so runs are directly comparable. The weakest fold is mostly long lunches where eating is a small part of the session, and the model misses eating there. Three people are at the bottom in every run; I'll check their sensor data next, which also feeds the data-quality assessment. The main message: differences between people are bigger than differences between model choices.</a:t>
+              <a:t>False positives are the failure that matters in free living, so the threshold should be set for them. The model outputs a probability; where we draw the line decides the trade-off. Best F1 treats a false alarm and a miss as equally bad. The other two options favour precision: F0.5, or a hard budget of false alarms per hour. The curve shows, for any budget, how much eating we still catch. Next step: train with the budget chosen on validation participants, so the reported number is not tuned on the test set. Negative examples from other ETS studies are the other lever, and they attack false positives directly.</a:t>
             </a:r>
             <a:endParaRPr lang="en-US" dirty="0"/>
           </a:p>
@@ -1796,6 +1797,94 @@
           <a:p>
             <a:r>
               <a:rPr lang="en-US" dirty="0"/>
+              <a:t>The folds are fixed on purpose, so runs are directly comparable. The weakest fold is mostly long lunches where eating is a small part of the session, and the model misses eating there. Three people are at the bottom in every run; I'll check their sensor data next, which also feeds the data-quality assessment. The main message: differences between people are bigger than differences between model choices.</a:t>
+            </a:r>
+            <a:endParaRPr lang="en-US" dirty="0"/>
+          </a:p>
+        </p:txBody>
+      </p:sp>
+      <p:sp>
+        <p:nvSpPr>
+          <p:cNvPr id="4" name="Slide Number Placeholder 3"/>
+          <p:cNvSpPr>
+            <a:spLocks noGrp="1"/>
+          </p:cNvSpPr>
+          <p:nvPr>
+            <p:ph type="sldNum" sz="quarter" idx="10"/>
+          </p:nvPr>
+        </p:nvSpPr>
+        <p:spPr/>
+        <p:txBody>
+          <a:bodyPr/>
+          <a:lstStyle/>
+          <a:p>
+            <a:fld id="{F7021451-1387-4CA6-816F-3879F97B5CBC}" type="slidenum">
+              <a:rPr lang="en-US"/>
+              <a:t>7</a:t>
+            </a:fld>
+            <a:endParaRPr lang="en-US"/>
+          </a:p>
+        </p:txBody>
+      </p:sp>
+    </p:spTree>
+    <p:extLst>
+      <p:ext uri="{BB962C8B-B14F-4D97-AF65-F5344CB8AC3E}">
+        <p14:creationId xmlns:p14="http://schemas.microsoft.com/office/powerpoint/2010/main" val="1024086991"/>
+      </p:ext>
+    </p:extLst>
+  </p:cSld>
+  <p:clrMapOvr>
+    <a:masterClrMapping/>
+  </p:clrMapOvr>
+</p:notes>
+</file>
+
+<file path=ppt/notesSlides/notesSlide8.xml><?xml version="1.0" encoding="utf-8"?>
+<p:notes xmlns:a="http://schemas.openxmlformats.org/drawingml/2006/main" xmlns:r="http://schemas.openxmlformats.org/officeDocument/2006/relationships" xmlns:p="http://schemas.openxmlformats.org/presentationml/2006/main">
+  <p:cSld>
+    <p:spTree>
+      <p:nvGrpSpPr>
+        <p:cNvPr id="1" name=""/>
+        <p:cNvGrpSpPr/>
+        <p:nvPr/>
+      </p:nvGrpSpPr>
+      <p:grpSpPr>
+        <a:xfrm>
+          <a:off x="0" y="0"/>
+          <a:ext cx="0" cy="0"/>
+          <a:chOff x="0" y="0"/>
+          <a:chExt cx="0" cy="0"/>
+        </a:xfrm>
+      </p:grpSpPr>
+      <p:sp>
+        <p:nvSpPr>
+          <p:cNvPr id="2" name="Slide Image Placeholder 1"/>
+          <p:cNvSpPr>
+            <a:spLocks noGrp="1" noRot="1" noChangeAspect="1"/>
+          </p:cNvSpPr>
+          <p:nvPr>
+            <p:ph type="sldImg"/>
+          </p:nvPr>
+        </p:nvSpPr>
+        <p:spPr/>
+      </p:sp>
+      <p:sp>
+        <p:nvSpPr>
+          <p:cNvPr id="3" name="Notes Placeholder 2"/>
+          <p:cNvSpPr>
+            <a:spLocks noGrp="1"/>
+          </p:cNvSpPr>
+          <p:nvPr>
+            <p:ph type="body" idx="1"/>
+          </p:nvPr>
+        </p:nvSpPr>
+        <p:spPr/>
+        <p:txBody>
+          <a:bodyPr/>
+          <a:lstStyle/>
+          <a:p>
+            <a:r>
+              <a:rPr lang="en-US" dirty="0"/>
               <a:t>Every item from last week is either done, implemented and queued, or waiting on data. The sampling-rate, window and chew-weight experiments are one flag each now, so they can all run this week. The negative-examples idea is the one I need to plan with Siavash, since those recordings need to go into the same database first.</a:t>
             </a:r>
             <a:endParaRPr lang="en-US" dirty="0"/>
@@ -1819,7 +1908,7 @@
           <a:p>
             <a:fld id="{F7021451-1387-4CA6-816F-3879F97B5CBC}" type="slidenum">
               <a:rPr lang="en-US"/>
-              <a:t>7</a:t>
+              <a:t>8</a:t>
             </a:fld>
             <a:endParaRPr lang="en-US"/>
           </a:p>
@@ -8114,6 +8203,801 @@
                 <a:ea typeface="Arial" pitchFamily="34" charset="-122"/>
                 <a:cs typeface="Arial" pitchFamily="34" charset="-120"/>
               </a:rPr>
+              <a:t>Reducing False Positives</a:t>
+            </a:r>
+            <a:endParaRPr lang="en-US" sz="2800" dirty="0"/>
+          </a:p>
+        </p:txBody>
+      </p:sp>
+      <p:graphicFrame>
+        <p:nvGraphicFramePr>
+          <p:cNvPr id="7" name="Table 0"/>
+          <p:cNvGraphicFramePr>
+            <a:graphicFrameLocks noGrp="1"/>
+          </p:cNvGraphicFramePr>
+          <p:nvPr>
+            <p:extLst>
+              <p:ext uri="{D42A27DB-BD31-4B8C-83A1-F6EECF244321}">
+                <p14:modId xmlns:p14="http://schemas.microsoft.com/office/powerpoint/2010/main" val="1579011935"/>
+              </p:ext>
+            </p:extLst>
+          </p:nvPr>
+        </p:nvGraphicFramePr>
+        <p:xfrm>
+          <a:off x="457200" y="960120"/>
+          <a:ext cx="4023360" cy="914400"/>
+        </p:xfrm>
+        <a:graphic>
+          <a:graphicData uri="http://schemas.openxmlformats.org/drawingml/2006/table">
+            <a:tbl>
+              <a:tblPr/>
+              <a:tblGrid>
+                <a:gridCol w="1371600"/>
+                <a:gridCol w="2651760"/>
+              </a:tblGrid>
+              <a:tr h="0">
+                <a:tc>
+                  <a:txBody>
+                    <a:bodyPr/>
+                    <a:lstStyle/>
+                    <a:p>
+                      <a:pPr algn="l" indent="0" marL="0">
+                        <a:buNone/>
+                      </a:pPr>
+                      <a:r>
+                        <a:rPr lang="en-US" sz="1100" b="1" dirty="0">
+                          <a:solidFill>
+                            <a:srgbClr val="222222"/>
+                          </a:solidFill>
+                          <a:latin typeface="Arial" pitchFamily="34" charset="0"/>
+                          <a:ea typeface="Arial" pitchFamily="34" charset="-122"/>
+                          <a:cs typeface="Arial" pitchFamily="34" charset="-120"/>
+                        </a:rPr>
+                        <a:t>Operating point</a:t>
+                      </a:r>
+                      <a:endParaRPr lang="en-US" sz="1100" dirty="0">
+                        <a:latin typeface="Arial" charset="0"/>
+                        <a:ea typeface="Arial" charset="0"/>
+                        <a:cs typeface="Arial" charset="0"/>
+                      </a:endParaRPr>
+                    </a:p>
+                  </a:txBody>
+                  <a:tcPr marL="45720" marR="45720" marT="45720" marB="45720" anchor="ctr">
+                    <a:lnL w="9525" cap="flat" cmpd="sng" algn="ctr">
+                      <a:solidFill>
+                        <a:srgbClr val="BFBFBF"/>
+                      </a:solidFill>
+                      <a:prstDash val="solid"/>
+                      <a:round/>
+                      <a:headEnd type="none" w="med" len="med"/>
+                      <a:tailEnd type="none" w="med" len="med"/>
+                    </a:lnL>
+                    <a:lnR w="9525" cap="flat" cmpd="sng" algn="ctr">
+                      <a:solidFill>
+                        <a:srgbClr val="BFBFBF"/>
+                      </a:solidFill>
+                      <a:prstDash val="solid"/>
+                      <a:round/>
+                      <a:headEnd type="none" w="med" len="med"/>
+                      <a:tailEnd type="none" w="med" len="med"/>
+                    </a:lnR>
+                    <a:lnT w="9525" cap="flat" cmpd="sng" algn="ctr">
+                      <a:solidFill>
+                        <a:srgbClr val="BFBFBF"/>
+                      </a:solidFill>
+                      <a:prstDash val="solid"/>
+                      <a:round/>
+                      <a:headEnd type="none" w="med" len="med"/>
+                      <a:tailEnd type="none" w="med" len="med"/>
+                    </a:lnT>
+                    <a:lnB w="9525" cap="flat" cmpd="sng" algn="ctr">
+                      <a:solidFill>
+                        <a:srgbClr val="BFBFBF"/>
+                      </a:solidFill>
+                      <a:prstDash val="solid"/>
+                      <a:round/>
+                      <a:headEnd type="none" w="med" len="med"/>
+                      <a:tailEnd type="none" w="med" len="med"/>
+                    </a:lnB>
+                    <a:solidFill>
+                      <a:srgbClr val="EFEFEF"/>
+                    </a:solidFill>
+                  </a:tcPr>
+                </a:tc>
+                <a:tc>
+                  <a:txBody>
+                    <a:bodyPr/>
+                    <a:lstStyle/>
+                    <a:p>
+                      <a:pPr algn="l" indent="0" marL="0">
+                        <a:buNone/>
+                      </a:pPr>
+                      <a:r>
+                        <a:rPr lang="en-US" sz="1100" b="1" dirty="0">
+                          <a:solidFill>
+                            <a:srgbClr val="222222"/>
+                          </a:solidFill>
+                          <a:latin typeface="Arial" pitchFamily="34" charset="0"/>
+                          <a:ea typeface="Arial" pitchFamily="34" charset="-122"/>
+                          <a:cs typeface="Arial" pitchFamily="34" charset="-120"/>
+                        </a:rPr>
+                        <a:t>How the threshold is chosen</a:t>
+                      </a:r>
+                      <a:endParaRPr lang="en-US" sz="1100" dirty="0">
+                        <a:latin typeface="Arial" charset="0"/>
+                        <a:ea typeface="Arial" charset="0"/>
+                        <a:cs typeface="Arial" charset="0"/>
+                      </a:endParaRPr>
+                    </a:p>
+                  </a:txBody>
+                  <a:tcPr marL="45720" marR="45720" marT="45720" marB="45720" anchor="ctr">
+                    <a:lnL w="9525" cap="flat" cmpd="sng" algn="ctr">
+                      <a:solidFill>
+                        <a:srgbClr val="BFBFBF"/>
+                      </a:solidFill>
+                      <a:prstDash val="solid"/>
+                      <a:round/>
+                      <a:headEnd type="none" w="med" len="med"/>
+                      <a:tailEnd type="none" w="med" len="med"/>
+                    </a:lnL>
+                    <a:lnR w="9525" cap="flat" cmpd="sng" algn="ctr">
+                      <a:solidFill>
+                        <a:srgbClr val="BFBFBF"/>
+                      </a:solidFill>
+                      <a:prstDash val="solid"/>
+                      <a:round/>
+                      <a:headEnd type="none" w="med" len="med"/>
+                      <a:tailEnd type="none" w="med" len="med"/>
+                    </a:lnR>
+                    <a:lnT w="9525" cap="flat" cmpd="sng" algn="ctr">
+                      <a:solidFill>
+                        <a:srgbClr val="BFBFBF"/>
+                      </a:solidFill>
+                      <a:prstDash val="solid"/>
+                      <a:round/>
+                      <a:headEnd type="none" w="med" len="med"/>
+                      <a:tailEnd type="none" w="med" len="med"/>
+                    </a:lnT>
+                    <a:lnB w="9525" cap="flat" cmpd="sng" algn="ctr">
+                      <a:solidFill>
+                        <a:srgbClr val="BFBFBF"/>
+                      </a:solidFill>
+                      <a:prstDash val="solid"/>
+                      <a:round/>
+                      <a:headEnd type="none" w="med" len="med"/>
+                      <a:tailEnd type="none" w="med" len="med"/>
+                    </a:lnB>
+                    <a:solidFill>
+                      <a:srgbClr val="EFEFEF"/>
+                    </a:solidFill>
+                  </a:tcPr>
+                </a:tc>
+              </a:tr>
+              <a:tr h="0">
+                <a:tc>
+                  <a:txBody>
+                    <a:bodyPr/>
+                    <a:lstStyle/>
+                    <a:p>
+                      <a:pPr algn="l" indent="0" marL="0">
+                        <a:buNone/>
+                      </a:pPr>
+                      <a:r>
+                        <a:rPr lang="en-US" sz="1100" dirty="0">
+                          <a:solidFill>
+                            <a:srgbClr val="222222"/>
+                          </a:solidFill>
+                          <a:latin typeface="Arial" pitchFamily="34" charset="0"/>
+                          <a:ea typeface="Arial" pitchFamily="34" charset="-122"/>
+                          <a:cs typeface="Arial" pitchFamily="34" charset="-120"/>
+                        </a:rPr>
+                        <a:t>Now: best F1</a:t>
+                      </a:r>
+                      <a:endParaRPr lang="en-US" sz="1100" dirty="0">
+                        <a:latin typeface="Arial" charset="0"/>
+                        <a:ea typeface="Arial" charset="0"/>
+                        <a:cs typeface="Arial" charset="0"/>
+                      </a:endParaRPr>
+                    </a:p>
+                  </a:txBody>
+                  <a:tcPr marL="45720" marR="45720" marT="45720" marB="45720" anchor="ctr">
+                    <a:lnL w="9525" cap="flat" cmpd="sng" algn="ctr">
+                      <a:solidFill>
+                        <a:srgbClr val="BFBFBF"/>
+                      </a:solidFill>
+                      <a:prstDash val="solid"/>
+                      <a:round/>
+                      <a:headEnd type="none" w="med" len="med"/>
+                      <a:tailEnd type="none" w="med" len="med"/>
+                    </a:lnL>
+                    <a:lnR w="9525" cap="flat" cmpd="sng" algn="ctr">
+                      <a:solidFill>
+                        <a:srgbClr val="BFBFBF"/>
+                      </a:solidFill>
+                      <a:prstDash val="solid"/>
+                      <a:round/>
+                      <a:headEnd type="none" w="med" len="med"/>
+                      <a:tailEnd type="none" w="med" len="med"/>
+                    </a:lnR>
+                    <a:lnT w="9525" cap="flat" cmpd="sng" algn="ctr">
+                      <a:solidFill>
+                        <a:srgbClr val="BFBFBF"/>
+                      </a:solidFill>
+                      <a:prstDash val="solid"/>
+                      <a:round/>
+                      <a:headEnd type="none" w="med" len="med"/>
+                      <a:tailEnd type="none" w="med" len="med"/>
+                    </a:lnT>
+                    <a:lnB w="9525" cap="flat" cmpd="sng" algn="ctr">
+                      <a:solidFill>
+                        <a:srgbClr val="BFBFBF"/>
+                      </a:solidFill>
+                      <a:prstDash val="solid"/>
+                      <a:round/>
+                      <a:headEnd type="none" w="med" len="med"/>
+                      <a:tailEnd type="none" w="med" len="med"/>
+                    </a:lnB>
+                    <a:solidFill>
+                      <a:srgbClr val="FFFFFF"/>
+                    </a:solidFill>
+                  </a:tcPr>
+                </a:tc>
+                <a:tc>
+                  <a:txBody>
+                    <a:bodyPr/>
+                    <a:lstStyle/>
+                    <a:p>
+                      <a:pPr algn="l" indent="0" marL="0">
+                        <a:buNone/>
+                      </a:pPr>
+                      <a:r>
+                        <a:rPr lang="en-US" sz="1100" dirty="0">
+                          <a:solidFill>
+                            <a:srgbClr val="222222"/>
+                          </a:solidFill>
+                          <a:latin typeface="Arial" pitchFamily="34" charset="0"/>
+                          <a:ea typeface="Arial" pitchFamily="34" charset="-122"/>
+                          <a:cs typeface="Arial" pitchFamily="34" charset="-120"/>
+                        </a:rPr>
+                        <a:t>Balances false alarms and misses equally</a:t>
+                      </a:r>
+                      <a:endParaRPr lang="en-US" sz="1100" dirty="0">
+                        <a:latin typeface="Arial" charset="0"/>
+                        <a:ea typeface="Arial" charset="0"/>
+                        <a:cs typeface="Arial" charset="0"/>
+                      </a:endParaRPr>
+                    </a:p>
+                  </a:txBody>
+                  <a:tcPr marL="45720" marR="45720" marT="45720" marB="45720" anchor="ctr">
+                    <a:lnL w="9525" cap="flat" cmpd="sng" algn="ctr">
+                      <a:solidFill>
+                        <a:srgbClr val="BFBFBF"/>
+                      </a:solidFill>
+                      <a:prstDash val="solid"/>
+                      <a:round/>
+                      <a:headEnd type="none" w="med" len="med"/>
+                      <a:tailEnd type="none" w="med" len="med"/>
+                    </a:lnL>
+                    <a:lnR w="9525" cap="flat" cmpd="sng" algn="ctr">
+                      <a:solidFill>
+                        <a:srgbClr val="BFBFBF"/>
+                      </a:solidFill>
+                      <a:prstDash val="solid"/>
+                      <a:round/>
+                      <a:headEnd type="none" w="med" len="med"/>
+                      <a:tailEnd type="none" w="med" len="med"/>
+                    </a:lnR>
+                    <a:lnT w="9525" cap="flat" cmpd="sng" algn="ctr">
+                      <a:solidFill>
+                        <a:srgbClr val="BFBFBF"/>
+                      </a:solidFill>
+                      <a:prstDash val="solid"/>
+                      <a:round/>
+                      <a:headEnd type="none" w="med" len="med"/>
+                      <a:tailEnd type="none" w="med" len="med"/>
+                    </a:lnT>
+                    <a:lnB w="9525" cap="flat" cmpd="sng" algn="ctr">
+                      <a:solidFill>
+                        <a:srgbClr val="BFBFBF"/>
+                      </a:solidFill>
+                      <a:prstDash val="solid"/>
+                      <a:round/>
+                      <a:headEnd type="none" w="med" len="med"/>
+                      <a:tailEnd type="none" w="med" len="med"/>
+                    </a:lnB>
+                    <a:solidFill>
+                      <a:srgbClr val="FFFFFF"/>
+                    </a:solidFill>
+                  </a:tcPr>
+                </a:tc>
+              </a:tr>
+              <a:tr h="0">
+                <a:tc>
+                  <a:txBody>
+                    <a:bodyPr/>
+                    <a:lstStyle/>
+                    <a:p>
+                      <a:pPr algn="l" indent="0" marL="0">
+                        <a:buNone/>
+                      </a:pPr>
+                      <a:r>
+                        <a:rPr lang="en-US" sz="1100" dirty="0">
+                          <a:solidFill>
+                            <a:srgbClr val="222222"/>
+                          </a:solidFill>
+                          <a:latin typeface="Arial" pitchFamily="34" charset="0"/>
+                          <a:ea typeface="Arial" pitchFamily="34" charset="-122"/>
+                          <a:cs typeface="Arial" pitchFamily="34" charset="-120"/>
+                        </a:rPr>
+                        <a:t>F0.5</a:t>
+                      </a:r>
+                      <a:endParaRPr lang="en-US" sz="1100" dirty="0">
+                        <a:latin typeface="Arial" charset="0"/>
+                        <a:ea typeface="Arial" charset="0"/>
+                        <a:cs typeface="Arial" charset="0"/>
+                      </a:endParaRPr>
+                    </a:p>
+                  </a:txBody>
+                  <a:tcPr marL="45720" marR="45720" marT="45720" marB="45720" anchor="ctr">
+                    <a:lnL w="9525" cap="flat" cmpd="sng" algn="ctr">
+                      <a:solidFill>
+                        <a:srgbClr val="BFBFBF"/>
+                      </a:solidFill>
+                      <a:prstDash val="solid"/>
+                      <a:round/>
+                      <a:headEnd type="none" w="med" len="med"/>
+                      <a:tailEnd type="none" w="med" len="med"/>
+                    </a:lnL>
+                    <a:lnR w="9525" cap="flat" cmpd="sng" algn="ctr">
+                      <a:solidFill>
+                        <a:srgbClr val="BFBFBF"/>
+                      </a:solidFill>
+                      <a:prstDash val="solid"/>
+                      <a:round/>
+                      <a:headEnd type="none" w="med" len="med"/>
+                      <a:tailEnd type="none" w="med" len="med"/>
+                    </a:lnR>
+                    <a:lnT w="9525" cap="flat" cmpd="sng" algn="ctr">
+                      <a:solidFill>
+                        <a:srgbClr val="BFBFBF"/>
+                      </a:solidFill>
+                      <a:prstDash val="solid"/>
+                      <a:round/>
+                      <a:headEnd type="none" w="med" len="med"/>
+                      <a:tailEnd type="none" w="med" len="med"/>
+                    </a:lnT>
+                    <a:lnB w="9525" cap="flat" cmpd="sng" algn="ctr">
+                      <a:solidFill>
+                        <a:srgbClr val="BFBFBF"/>
+                      </a:solidFill>
+                      <a:prstDash val="solid"/>
+                      <a:round/>
+                      <a:headEnd type="none" w="med" len="med"/>
+                      <a:tailEnd type="none" w="med" len="med"/>
+                    </a:lnB>
+                    <a:solidFill>
+                      <a:srgbClr val="FFFFFF"/>
+                    </a:solidFill>
+                  </a:tcPr>
+                </a:tc>
+                <a:tc>
+                  <a:txBody>
+                    <a:bodyPr/>
+                    <a:lstStyle/>
+                    <a:p>
+                      <a:pPr algn="l" indent="0" marL="0">
+                        <a:buNone/>
+                      </a:pPr>
+                      <a:r>
+                        <a:rPr lang="en-US" sz="1100" dirty="0">
+                          <a:solidFill>
+                            <a:srgbClr val="222222"/>
+                          </a:solidFill>
+                          <a:latin typeface="Arial" pitchFamily="34" charset="0"/>
+                          <a:ea typeface="Arial" pitchFamily="34" charset="-122"/>
+                          <a:cs typeface="Arial" pitchFamily="34" charset="-120"/>
+                        </a:rPr>
+                        <a:t>Counts a false alarm twice as costly as a miss</a:t>
+                      </a:r>
+                      <a:endParaRPr lang="en-US" sz="1100" dirty="0">
+                        <a:latin typeface="Arial" charset="0"/>
+                        <a:ea typeface="Arial" charset="0"/>
+                        <a:cs typeface="Arial" charset="0"/>
+                      </a:endParaRPr>
+                    </a:p>
+                  </a:txBody>
+                  <a:tcPr marL="45720" marR="45720" marT="45720" marB="45720" anchor="ctr">
+                    <a:lnL w="9525" cap="flat" cmpd="sng" algn="ctr">
+                      <a:solidFill>
+                        <a:srgbClr val="BFBFBF"/>
+                      </a:solidFill>
+                      <a:prstDash val="solid"/>
+                      <a:round/>
+                      <a:headEnd type="none" w="med" len="med"/>
+                      <a:tailEnd type="none" w="med" len="med"/>
+                    </a:lnL>
+                    <a:lnR w="9525" cap="flat" cmpd="sng" algn="ctr">
+                      <a:solidFill>
+                        <a:srgbClr val="BFBFBF"/>
+                      </a:solidFill>
+                      <a:prstDash val="solid"/>
+                      <a:round/>
+                      <a:headEnd type="none" w="med" len="med"/>
+                      <a:tailEnd type="none" w="med" len="med"/>
+                    </a:lnR>
+                    <a:lnT w="9525" cap="flat" cmpd="sng" algn="ctr">
+                      <a:solidFill>
+                        <a:srgbClr val="BFBFBF"/>
+                      </a:solidFill>
+                      <a:prstDash val="solid"/>
+                      <a:round/>
+                      <a:headEnd type="none" w="med" len="med"/>
+                      <a:tailEnd type="none" w="med" len="med"/>
+                    </a:lnT>
+                    <a:lnB w="9525" cap="flat" cmpd="sng" algn="ctr">
+                      <a:solidFill>
+                        <a:srgbClr val="BFBFBF"/>
+                      </a:solidFill>
+                      <a:prstDash val="solid"/>
+                      <a:round/>
+                      <a:headEnd type="none" w="med" len="med"/>
+                      <a:tailEnd type="none" w="med" len="med"/>
+                    </a:lnB>
+                    <a:solidFill>
+                      <a:srgbClr val="FFFFFF"/>
+                    </a:solidFill>
+                  </a:tcPr>
+                </a:tc>
+              </a:tr>
+              <a:tr h="0">
+                <a:tc>
+                  <a:txBody>
+                    <a:bodyPr/>
+                    <a:lstStyle/>
+                    <a:p>
+                      <a:pPr algn="l" indent="0" marL="0">
+                        <a:buNone/>
+                      </a:pPr>
+                      <a:r>
+                        <a:rPr lang="en-US" sz="1100" dirty="0">
+                          <a:solidFill>
+                            <a:srgbClr val="222222"/>
+                          </a:solidFill>
+                          <a:latin typeface="Arial" pitchFamily="34" charset="0"/>
+                          <a:ea typeface="Arial" pitchFamily="34" charset="-122"/>
+                          <a:cs typeface="Arial" pitchFamily="34" charset="-120"/>
+                        </a:rPr>
+                        <a:t>False-alarm budget</a:t>
+                      </a:r>
+                      <a:endParaRPr lang="en-US" sz="1100" dirty="0">
+                        <a:latin typeface="Arial" charset="0"/>
+                        <a:ea typeface="Arial" charset="0"/>
+                        <a:cs typeface="Arial" charset="0"/>
+                      </a:endParaRPr>
+                    </a:p>
+                  </a:txBody>
+                  <a:tcPr marL="45720" marR="45720" marT="45720" marB="45720" anchor="ctr">
+                    <a:lnL w="9525" cap="flat" cmpd="sng" algn="ctr">
+                      <a:solidFill>
+                        <a:srgbClr val="BFBFBF"/>
+                      </a:solidFill>
+                      <a:prstDash val="solid"/>
+                      <a:round/>
+                      <a:headEnd type="none" w="med" len="med"/>
+                      <a:tailEnd type="none" w="med" len="med"/>
+                    </a:lnL>
+                    <a:lnR w="9525" cap="flat" cmpd="sng" algn="ctr">
+                      <a:solidFill>
+                        <a:srgbClr val="BFBFBF"/>
+                      </a:solidFill>
+                      <a:prstDash val="solid"/>
+                      <a:round/>
+                      <a:headEnd type="none" w="med" len="med"/>
+                      <a:tailEnd type="none" w="med" len="med"/>
+                    </a:lnR>
+                    <a:lnT w="9525" cap="flat" cmpd="sng" algn="ctr">
+                      <a:solidFill>
+                        <a:srgbClr val="BFBFBF"/>
+                      </a:solidFill>
+                      <a:prstDash val="solid"/>
+                      <a:round/>
+                      <a:headEnd type="none" w="med" len="med"/>
+                      <a:tailEnd type="none" w="med" len="med"/>
+                    </a:lnT>
+                    <a:lnB w="9525" cap="flat" cmpd="sng" algn="ctr">
+                      <a:solidFill>
+                        <a:srgbClr val="BFBFBF"/>
+                      </a:solidFill>
+                      <a:prstDash val="solid"/>
+                      <a:round/>
+                      <a:headEnd type="none" w="med" len="med"/>
+                      <a:tailEnd type="none" w="med" len="med"/>
+                    </a:lnB>
+                    <a:solidFill>
+                      <a:srgbClr val="FFFFFF"/>
+                    </a:solidFill>
+                  </a:tcPr>
+                </a:tc>
+                <a:tc>
+                  <a:txBody>
+                    <a:bodyPr/>
+                    <a:lstStyle/>
+                    <a:p>
+                      <a:pPr algn="l" indent="0" marL="0">
+                        <a:buNone/>
+                      </a:pPr>
+                      <a:r>
+                        <a:rPr lang="en-US" sz="1100" dirty="0">
+                          <a:solidFill>
+                            <a:srgbClr val="222222"/>
+                          </a:solidFill>
+                          <a:latin typeface="Arial" pitchFamily="34" charset="0"/>
+                          <a:ea typeface="Arial" pitchFamily="34" charset="-122"/>
+                          <a:cs typeface="Arial" pitchFamily="34" charset="-120"/>
+                        </a:rPr>
+                        <a:t>Catches as much eating as possible within N false alarms per hour</a:t>
+                      </a:r>
+                      <a:endParaRPr lang="en-US" sz="1100" dirty="0">
+                        <a:latin typeface="Arial" charset="0"/>
+                        <a:ea typeface="Arial" charset="0"/>
+                        <a:cs typeface="Arial" charset="0"/>
+                      </a:endParaRPr>
+                    </a:p>
+                  </a:txBody>
+                  <a:tcPr marL="45720" marR="45720" marT="45720" marB="45720" anchor="ctr">
+                    <a:lnL w="9525" cap="flat" cmpd="sng" algn="ctr">
+                      <a:solidFill>
+                        <a:srgbClr val="BFBFBF"/>
+                      </a:solidFill>
+                      <a:prstDash val="solid"/>
+                      <a:round/>
+                      <a:headEnd type="none" w="med" len="med"/>
+                      <a:tailEnd type="none" w="med" len="med"/>
+                    </a:lnL>
+                    <a:lnR w="9525" cap="flat" cmpd="sng" algn="ctr">
+                      <a:solidFill>
+                        <a:srgbClr val="BFBFBF"/>
+                      </a:solidFill>
+                      <a:prstDash val="solid"/>
+                      <a:round/>
+                      <a:headEnd type="none" w="med" len="med"/>
+                      <a:tailEnd type="none" w="med" len="med"/>
+                    </a:lnR>
+                    <a:lnT w="9525" cap="flat" cmpd="sng" algn="ctr">
+                      <a:solidFill>
+                        <a:srgbClr val="BFBFBF"/>
+                      </a:solidFill>
+                      <a:prstDash val="solid"/>
+                      <a:round/>
+                      <a:headEnd type="none" w="med" len="med"/>
+                      <a:tailEnd type="none" w="med" len="med"/>
+                    </a:lnT>
+                    <a:lnB w="9525" cap="flat" cmpd="sng" algn="ctr">
+                      <a:solidFill>
+                        <a:srgbClr val="BFBFBF"/>
+                      </a:solidFill>
+                      <a:prstDash val="solid"/>
+                      <a:round/>
+                      <a:headEnd type="none" w="med" len="med"/>
+                      <a:tailEnd type="none" w="med" len="med"/>
+                    </a:lnB>
+                    <a:solidFill>
+                      <a:srgbClr val="FFFFFF"/>
+                    </a:solidFill>
+                  </a:tcPr>
+                </a:tc>
+              </a:tr>
+            </a:tbl>
+          </a:graphicData>
+        </a:graphic>
+      </p:graphicFrame>
+      <p:sp>
+        <p:nvSpPr>
+          <p:cNvPr id="4" name="Text 1"/>
+          <p:cNvSpPr txBox="1"/>
+          <p:nvPr/>
+        </p:nvSpPr>
+        <p:spPr>
+          <a:xfrm>
+            <a:off x="457200" y="2514600"/>
+            <a:ext cx="4023360" cy="2194560"/>
+          </a:xfrm>
+          <a:prstGeom prst="rect">
+            <a:avLst/>
+          </a:prstGeom>
+          <a:noFill/>
+          <a:ln/>
+        </p:spPr>
+        <p:txBody>
+          <a:bodyPr wrap="square" rtlCol="0" anchor="t"/>
+          <a:lstStyle/>
+          <a:p>
+            <a:pPr marL="342900" indent="-342900">
+              <a:spcAft>
+                <a:spcPts val="600"/>
+              </a:spcAft>
+              <a:buSzPct val="100000"/>
+              <a:buChar char="•"/>
+            </a:pPr>
+            <a:r>
+              <a:rPr lang="en-US" sz="1400" dirty="0">
+                <a:solidFill>
+                  <a:srgbClr val="222222"/>
+                </a:solidFill>
+                <a:latin typeface="Arial" pitchFamily="34" charset="0"/>
+                <a:ea typeface="Arial" pitchFamily="34" charset="-122"/>
+                <a:cs typeface="Arial" pitchFamily="34" charset="-120"/>
+              </a:rPr>
+              <a:t>Current model: 32 false alarms per hour of non-eating, precision 0.88</a:t>
+            </a:r>
+            <a:endParaRPr lang="en-US" sz="1400" dirty="0"/>
+          </a:p>
+          <a:p>
+            <a:pPr marL="342900" indent="-342900">
+              <a:spcAft>
+                <a:spcPts val="600"/>
+              </a:spcAft>
+              <a:buSzPct val="100000"/>
+              <a:buChar char="•"/>
+            </a:pPr>
+            <a:r>
+              <a:rPr lang="en-US" sz="1400" dirty="0">
+                <a:solidFill>
+                  <a:srgbClr val="222222"/>
+                </a:solidFill>
+                <a:latin typeface="Arial" pitchFamily="34" charset="0"/>
+                <a:ea typeface="Arial" pitchFamily="34" charset="-122"/>
+                <a:cs typeface="Arial" pitchFamily="34" charset="-120"/>
+              </a:rPr>
+              <a:t>Threshold always chosen on validation participants, never the test person</a:t>
+            </a:r>
+            <a:endParaRPr lang="en-US" sz="1400" dirty="0"/>
+          </a:p>
+          <a:p>
+            <a:pPr marL="342900" indent="-342900">
+              <a:spcAft>
+                <a:spcPts val="600"/>
+              </a:spcAft>
+              <a:buSzPct val="100000"/>
+              <a:buChar char="•"/>
+            </a:pPr>
+            <a:r>
+              <a:rPr lang="en-US" sz="1400" dirty="0">
+                <a:solidFill>
+                  <a:srgbClr val="222222"/>
+                </a:solidFill>
+                <a:latin typeface="Arial" pitchFamily="34" charset="0"/>
+                <a:ea typeface="Arial" pitchFamily="34" charset="-122"/>
+                <a:cs typeface="Arial" pitchFamily="34" charset="-120"/>
+              </a:rPr>
+              <a:t>No retraining needed to see the trade-off: the curve comes from saved predictions</a:t>
+            </a:r>
+            <a:endParaRPr lang="en-US" sz="1400" dirty="0"/>
+          </a:p>
+        </p:txBody>
+      </p:sp>
+      <p:sp>
+        <p:nvSpPr>
+          <p:cNvPr id="5" name="Shape 2"/>
+          <p:cNvSpPr/>
+          <p:nvPr/>
+        </p:nvSpPr>
+        <p:spPr>
+          <a:xfrm>
+            <a:off x="4754880" y="960120"/>
+            <a:ext cx="3931920" cy="3749040"/>
+          </a:xfrm>
+          <a:prstGeom prst="rect">
+            <a:avLst/>
+          </a:prstGeom>
+          <a:solidFill>
+            <a:srgbClr val="FFFFFF"/>
+          </a:solidFill>
+          <a:ln w="9525">
+            <a:solidFill>
+              <a:srgbClr val="BFBFBF"/>
+            </a:solidFill>
+            <a:prstDash val="dash"/>
+          </a:ln>
+        </p:spPr>
+      </p:sp>
+      <p:sp>
+        <p:nvSpPr>
+          <p:cNvPr id="6" name="Text 3"/>
+          <p:cNvSpPr txBox="1"/>
+          <p:nvPr/>
+        </p:nvSpPr>
+        <p:spPr>
+          <a:xfrm>
+            <a:off x="4754880" y="2651760"/>
+            <a:ext cx="3931920" cy="365760"/>
+          </a:xfrm>
+          <a:prstGeom prst="rect">
+            <a:avLst/>
+          </a:prstGeom>
+          <a:noFill/>
+          <a:ln/>
+        </p:spPr>
+        <p:txBody>
+          <a:bodyPr wrap="square" lIns="0" tIns="0" rIns="0" bIns="0" rtlCol="0" anchor="ctr"/>
+          <a:lstStyle/>
+          <a:p>
+            <a:pPr algn="ctr" indent="0" marL="0">
+              <a:buNone/>
+            </a:pPr>
+            <a:r>
+              <a:rPr lang="en-US" sz="1100" dirty="0">
+                <a:solidFill>
+                  <a:srgbClr val="666666"/>
+                </a:solidFill>
+                <a:latin typeface="Arial" pitchFamily="34" charset="0"/>
+                <a:ea typeface="Arial" pitchFamily="34" charset="-122"/>
+                <a:cs typeface="Arial" pitchFamily="34" charset="-120"/>
+              </a:rPr>
+              <a:t>Paste figures\operating_curve.png here</a:t>
+            </a:r>
+            <a:endParaRPr lang="en-US" sz="1100" dirty="0"/>
+          </a:p>
+        </p:txBody>
+      </p:sp>
+    </p:spTree>
+  </p:cSld>
+  <p:clrMapOvr>
+    <a:masterClrMapping/>
+  </p:clrMapOvr>
+</p:sld>
+</file>
+
+<file path=ppt/slides/slide7.xml><?xml version="1.0" encoding="utf-8"?>
+<p:sld xmlns:a="http://schemas.openxmlformats.org/drawingml/2006/main" xmlns:r="http://schemas.openxmlformats.org/officeDocument/2006/relationships" xmlns:p="http://schemas.openxmlformats.org/presentationml/2006/main">
+  <p:cSld name="Slide 7">
+    <p:spTree>
+      <p:nvGrpSpPr>
+        <p:cNvPr id="1" name=""/>
+        <p:cNvGrpSpPr/>
+        <p:nvPr/>
+      </p:nvGrpSpPr>
+      <p:grpSpPr>
+        <a:xfrm>
+          <a:off x="0" y="0"/>
+          <a:ext cx="0" cy="0"/>
+          <a:chOff x="0" y="0"/>
+          <a:chExt cx="0" cy="0"/>
+        </a:xfrm>
+      </p:grpSpPr>
+      <p:sp>
+        <p:nvSpPr>
+          <p:cNvPr id="2" name="Text 0"/>
+          <p:cNvSpPr txBox="1"/>
+          <p:nvPr/>
+        </p:nvSpPr>
+        <p:spPr>
+          <a:xfrm>
+            <a:off x="457200" y="274320"/>
+            <a:ext cx="8229600" cy="548640"/>
+          </a:xfrm>
+          <a:prstGeom prst="rect">
+            <a:avLst/>
+          </a:prstGeom>
+          <a:noFill/>
+          <a:ln/>
+        </p:spPr>
+        <p:txBody>
+          <a:bodyPr wrap="square" lIns="0" tIns="0" rIns="0" bIns="0" rtlCol="0" anchor="ctr"/>
+          <a:lstStyle/>
+          <a:p>
+            <a:pPr indent="0" marL="0">
+              <a:buNone/>
+            </a:pPr>
+            <a:r>
+              <a:rPr lang="en-US" sz="2800" dirty="0">
+                <a:solidFill>
+                  <a:srgbClr val="222222"/>
+                </a:solidFill>
+                <a:latin typeface="Arial" pitchFamily="34" charset="0"/>
+                <a:ea typeface="Arial" pitchFamily="34" charset="-122"/>
+                <a:cs typeface="Arial" pitchFamily="34" charset="-120"/>
+              </a:rPr>
               <a:t>Where the Errors Are</a:t>
             </a:r>
             <a:endParaRPr lang="en-US" sz="2800" dirty="0"/>
@@ -8250,9 +9134,9 @@
 </p:sld>
 </file>
 
-<file path=ppt/slides/slide7.xml><?xml version="1.0" encoding="utf-8"?>
+<file path=ppt/slides/slide8.xml><?xml version="1.0" encoding="utf-8"?>
 <p:sld xmlns:a="http://schemas.openxmlformats.org/drawingml/2006/main" xmlns:r="http://schemas.openxmlformats.org/officeDocument/2006/relationships" xmlns:p="http://schemas.openxmlformats.org/presentationml/2006/main">
-  <p:cSld name="Slide 7">
+  <p:cSld name="Slide 8">
     <p:spTree>
       <p:nvGrpSpPr>
         <p:cNvPr id="1" name=""/>
@@ -8308,7 +9192,7 @@
       </p:sp>
       <p:graphicFrame>
         <p:nvGraphicFramePr>
-          <p:cNvPr id="8" name="Table 0"/>
+          <p:cNvPr id="9" name="Table 0"/>
           <p:cNvGraphicFramePr>
             <a:graphicFrameLocks noGrp="1"/>
           </p:cNvGraphicFramePr>

</xml_diff>

<commit_message>
Back the literature slide with verbatim quotes and page numbers
Each row now quotes Wang et al. 2017 or Diou et al. 2022 directly, from
the PDFs, instead of pairing a claim with a citation. The notes say
which components still need quotes from their primary papers, and that
the time-series-versus-FFT comparison is this project's own result.

Co-Authored-By: Claude Opus 5.5 <noreply@anthropic.com>
Claude-Session: https://claude.ai/code/session_017rMsJrfJb6LTfE8bFvgHeu
</commit_message>
<xml_diff>
--- a/docs/presentation/lab_meeting_new_slides.pptx
+++ b/docs/presentation/lab_meeting_new_slides.pptx
@@ -1258,18 +1258,9 @@
           <a:p>
             <a:r>
               <a:rPr lang="en-US" dirty="0"/>
-              <a:t>Every design choice has a published reason. The one that matters most is the input: the ECG literature (Hannun 2019) and Ghosh &amp; Sazonov 2022 on AIM-2 both feed raw signals to a CNN instead of hand-picked features. The two attention pieces are standard, cheap mechanisms (squeeze-and-excitation from Hu 2018, attention pooling from Ilse 2018). Transformers are the next experiment, but Vedovelli 2026 found a Transformer on smartwatch eating data had specificity of only 0.50, i.e. lots of false positives, so I'm testing it rather than assuming it helps.
-PAPER CHEAT SHEET (one line each):
-Doulah 2021 - introduced AIM-2; handcrafted features + SVM; F1 0.818 leave-one-out on 30 people.
-Ghosh &amp; Sazonov 2022 - compared 5 deep nets on raw AIM-2 signals; ResNet best at 93.5% balanced accuracy.
-Ghosh 2024 - turned accelerometer into a wavelet image and fused it with food photos; fusion cut false positives.
-Kyritsis 2021 - CNN + LSTM on raw smartwatch data for bites; F1 0.923.
-Diou 2022 - overview from the Thessaloniki group; CNN on raw earbud audio for chewing; self-supervised learning works with few labels.
-Stankoski 2021 - picked hard negative examples on purpose to reduce false positives.
-Wang 2024 - temporal CNN + self-attention on wrist IMU, 61 people, measures eating speed.
-Vedovelli 2026 - Transformer on smartwatch: good sensitivity (0.69), poor specificity (0.50).
-Hannun 2019 - 34-layer CNN on raw ECG beat cardiologists (F1 0.837 vs 0.780).
-Ikram 2025 - Transformer on ECG, 97% accuracy, but split by beats not patients, so it's optimistic.</a:t>
+              <a:t>Every row is a direct quote, with its page. Wang, Yan &amp; Oates 2017 is the standard reference for classifying time series with convolutional networks straight from the raw signal: their FCN is three conv + batch-norm + ReLU blocks, and z-normalisation is their only preprocessing, which is exactly our trunk and our normalisation. They compare against COTE, an ensemble built on features from both the time and frequency domains, and match or beat it from raw data. Diou et al. 2022 is the Thessaloniki group's review of their intake-monitoring work: the end-to-end model on raw smartwatch data beat every hand-engineered method, everything is evaluated leave-one-subject-out, and they report that walking at 1-3 Hz looks like chewing and causes false positives. That is the argument for keeping the accelerometer next to the optical sensor, and for choosing the threshold for the use case.
+Important: neither paper compares time series against an FFT on the same model. That comparison is our own result (next slides): F1 0.858 vs 0.796, false alarms 81 -&gt; 32 per hour.
+Still to quote from the primary papers (need the PDFs): squeeze-and-excitation (Hu et al. 2018), attention pooling (Ilse et al. 2018), the auxiliary chew head (Caruana 1997), and subject-wise versus record-wise validation (Saeb et al. 2017).</a:t>
             </a:r>
             <a:endParaRPr lang="en-US" dirty="0"/>
           </a:p>
@@ -2305,7 +2296,7 @@
           </p:nvPr>
         </p:nvGraphicFramePr>
         <p:xfrm>
-          <a:off x="457200" y="1005840"/>
+          <a:off x="457200" y="914400"/>
           <a:ext cx="8229600" cy="914400"/>
         </p:xfrm>
         <a:graphic>
@@ -2313,9 +2304,9 @@
             <a:tbl>
               <a:tblPr/>
               <a:tblGrid>
-                <a:gridCol w="2103120"/>
-                <a:gridCol w="3383280"/>
-                <a:gridCol w="2743200"/>
+                <a:gridCol w="2148840"/>
+                <a:gridCol w="4343400"/>
+                <a:gridCol w="1737360"/>
               </a:tblGrid>
               <a:tr h="0">
                 <a:tc>
@@ -2323,7 +2314,7 @@
                     <a:bodyPr/>
                     <a:lstStyle/>
                     <a:p>
-                      <a:pPr algn="ctr" indent="0" marL="0">
+                      <a:pPr algn="l" indent="0" marL="0">
                         <a:buNone/>
                       </a:pPr>
                       <a:r>
@@ -2391,7 +2382,7 @@
                     <a:bodyPr/>
                     <a:lstStyle/>
                     <a:p>
-                      <a:pPr algn="ctr" indent="0" marL="0">
+                      <a:pPr algn="l" indent="0" marL="0">
                         <a:buNone/>
                       </a:pPr>
                       <a:r>
@@ -2403,7 +2394,7 @@
                           <a:ea typeface="Arial" pitchFamily="34" charset="-122"/>
                           <a:cs typeface="Arial" pitchFamily="34" charset="-120"/>
                         </a:rPr>
-                        <a:t>What it does</a:t>
+                        <a:t>Published statement</a:t>
                       </a:r>
                       <a:endParaRPr lang="en-US" sz="1100" dirty="0">
                         <a:latin typeface="Arial" charset="0"/>
@@ -2459,7 +2450,7 @@
                     <a:bodyPr/>
                     <a:lstStyle/>
                     <a:p>
-                      <a:pPr algn="ctr" indent="0" marL="0">
+                      <a:pPr algn="l" indent="0" marL="0">
                         <a:buNone/>
                       </a:pPr>
                       <a:r>
@@ -2471,7 +2462,7 @@
                           <a:ea typeface="Arial" pitchFamily="34" charset="-122"/>
                           <a:cs typeface="Arial" pitchFamily="34" charset="-120"/>
                         </a:rPr>
-                        <a:t>Grounded in</a:t>
+                        <a:t>Source</a:t>
                       </a:r>
                       <a:endParaRPr lang="en-US" sz="1100" dirty="0">
                         <a:latin typeface="Arial" charset="0"/>
@@ -2541,7 +2532,7 @@
                           <a:ea typeface="Arial" pitchFamily="34" charset="-122"/>
                           <a:cs typeface="Arial" pitchFamily="34" charset="-120"/>
                         </a:rPr>
-                        <a:t>Time-series input, no FFT</a:t>
+                        <a:t>Raw time-series input, no FFT or hand-crafted features</a:t>
                       </a:r>
                       <a:endParaRPr lang="en-US" sz="1100" dirty="0">
                         <a:latin typeface="Arial" charset="0"/>
@@ -2609,7 +2600,7 @@
                           <a:ea typeface="Arial" pitchFamily="34" charset="-122"/>
                           <a:cs typeface="Arial" pitchFamily="34" charset="-120"/>
                         </a:rPr>
-                        <a:t>Keeps when chewing and bites happen, not just which rhythms are present</a:t>
+                        <a:t>“Our proposed baseline models are pure end-to-end without any heavy preprocessing on the raw data or feature crafting.”</a:t>
                       </a:r>
                       <a:endParaRPr lang="en-US" sz="1100" dirty="0">
                         <a:latin typeface="Arial" charset="0"/>
@@ -2677,7 +2668,7 @@
                           <a:ea typeface="Arial" pitchFamily="34" charset="-122"/>
                           <a:cs typeface="Arial" pitchFamily="34" charset="-120"/>
                         </a:rPr>
-                        <a:t>Hannun et al. 2019 (raw ECG CNN); Ghosh &amp; Sazonov 2022 (raw AIM-2 signals)</a:t>
+                        <a:t>Wang et al. 2017, p. 1</a:t>
                       </a:r>
                       <a:endParaRPr lang="en-US" sz="1100" dirty="0">
                         <a:latin typeface="Arial" charset="0"/>
@@ -2747,7 +2738,7 @@
                           <a:ea typeface="Arial" pitchFamily="34" charset="-122"/>
                           <a:cs typeface="Arial" pitchFamily="34" charset="-120"/>
                         </a:rPr>
-                        <a:t>Channel attention (squeeze-excite)</a:t>
+                        <a:t>Raw input for eating detection</a:t>
                       </a:r>
                       <a:endParaRPr lang="en-US" sz="1100" dirty="0">
                         <a:latin typeface="Arial" charset="0"/>
@@ -2815,7 +2806,7 @@
                           <a:ea typeface="Arial" pitchFamily="34" charset="-122"/>
                           <a:cs typeface="Arial" pitchFamily="34" charset="-120"/>
                         </a:rPr>
-                        <a:t>Weighs optical against accelerometer in every window</a:t>
+                        <a:t>“processes the raw inertial data (not using hand-engineered features)”; this end-to-end approach “outperforms all other methods”</a:t>
                       </a:r>
                       <a:endParaRPr lang="en-US" sz="1100" dirty="0">
                         <a:latin typeface="Arial" charset="0"/>
@@ -2883,7 +2874,7 @@
                           <a:ea typeface="Arial" pitchFamily="34" charset="-122"/>
                           <a:cs typeface="Arial" pitchFamily="34" charset="-120"/>
                         </a:rPr>
-                        <a:t>Hu et al. 2018</a:t>
+                        <a:t>Diou et al. 2022, pp. 4–5</a:t>
                       </a:r>
                       <a:endParaRPr lang="en-US" sz="1100" dirty="0">
                         <a:latin typeface="Arial" charset="0"/>
@@ -2953,7 +2944,7 @@
                           <a:ea typeface="Arial" pitchFamily="34" charset="-122"/>
                           <a:cs typeface="Arial" pitchFamily="34" charset="-120"/>
                         </a:rPr>
-                        <a:t>Attention pooling over time</a:t>
+                        <a:t>Per-window z-score normalisation</a:t>
                       </a:r>
                       <a:endParaRPr lang="en-US" sz="1100" dirty="0">
                         <a:latin typeface="Arial" charset="0"/>
@@ -3021,7 +3012,7 @@
                           <a:ea typeface="Arial" pitchFamily="34" charset="-122"/>
                           <a:cs typeface="Arial" pitchFamily="34" charset="-120"/>
                         </a:rPr>
-                        <a:t>Lets a 1-2 s bite dominate an 8 s window instead of being averaged away</a:t>
+                        <a:t>“The only preprocessing in our experiment is z-normalization”</a:t>
                       </a:r>
                       <a:endParaRPr lang="en-US" sz="1100" dirty="0">
                         <a:latin typeface="Arial" charset="0"/>
@@ -3089,7 +3080,7 @@
                           <a:ea typeface="Arial" pitchFamily="34" charset="-122"/>
                           <a:cs typeface="Arial" pitchFamily="34" charset="-120"/>
                         </a:rPr>
-                        <a:t>Ilse et al. 2018</a:t>
+                        <a:t>Wang et al. 2017, p. 3</a:t>
                       </a:r>
                       <a:endParaRPr lang="en-US" sz="1100" dirty="0">
                         <a:latin typeface="Arial" charset="0"/>
@@ -3159,7 +3150,7 @@
                           <a:ea typeface="Arial" pitchFamily="34" charset="-122"/>
                           <a:cs typeface="Arial" pitchFamily="34" charset="-120"/>
                         </a:rPr>
-                        <a:t>Auxiliary chew-count head</a:t>
+                        <a:t>Conv + batch norm + ReLU blocks</a:t>
                       </a:r>
                       <a:endParaRPr lang="en-US" sz="1100" dirty="0">
                         <a:latin typeface="Arial" charset="0"/>
@@ -3227,7 +3218,7 @@
                           <a:ea typeface="Arial" pitchFamily="34" charset="-122"/>
                           <a:cs typeface="Arial" pitchFamily="34" charset="-120"/>
                         </a:rPr>
-                        <a:t>Extra supervision from the chew labels; discarded after training</a:t>
+                        <a:t>“The basic block is a convolutional layer followed by a batch normalization layer [...] and a ReLU activation layer.”</a:t>
                       </a:r>
                       <a:endParaRPr lang="en-US" sz="1100" dirty="0">
                         <a:latin typeface="Arial" charset="0"/>
@@ -3295,7 +3286,7 @@
                           <a:ea typeface="Arial" pitchFamily="34" charset="-122"/>
                           <a:cs typeface="Arial" pitchFamily="34" charset="-120"/>
                         </a:rPr>
-                        <a:t>Caruana 1997 (multi-task learning)</a:t>
+                        <a:t>Wang et al. 2017, p. 2</a:t>
                       </a:r>
                       <a:endParaRPr lang="en-US" sz="1100" dirty="0">
                         <a:latin typeface="Arial" charset="0"/>
@@ -3365,7 +3356,7 @@
                           <a:ea typeface="Arial" pitchFamily="34" charset="-122"/>
                           <a:cs typeface="Arial" pitchFamily="34" charset="-120"/>
                         </a:rPr>
-                        <a:t>Participant-level validation</a:t>
+                        <a:t>Accelerometer alongside optical, weighted by channel attention</a:t>
                       </a:r>
                       <a:endParaRPr lang="en-US" sz="1100" dirty="0">
                         <a:latin typeface="Arial" charset="0"/>
@@ -3433,7 +3424,7 @@
                           <a:ea typeface="Arial" pitchFamily="34" charset="-122"/>
                           <a:cs typeface="Arial" pitchFamily="34" charset="-120"/>
                         </a:rPr>
-                        <a:t>Tests only on people the model has never seen</a:t>
+                        <a:t>“walking rhythm is similar to chewing (i.e. 1 to 3 Hz) [...] causing the classification models to yield high false-positive detections”</a:t>
                       </a:r>
                       <a:endParaRPr lang="en-US" sz="1100" dirty="0">
                         <a:latin typeface="Arial" charset="0"/>
@@ -3501,7 +3492,7 @@
                           <a:ea typeface="Arial" pitchFamily="34" charset="-122"/>
                           <a:cs typeface="Arial" pitchFamily="34" charset="-120"/>
                         </a:rPr>
-                        <a:t>Saeb et al. 2017; Doulah et al. 2021</a:t>
+                        <a:t>Diou et al. 2022, p. 8</a:t>
                       </a:r>
                       <a:endParaRPr lang="en-US" sz="1100" dirty="0">
                         <a:latin typeface="Arial" charset="0"/>
@@ -3571,7 +3562,7 @@
                           <a:ea typeface="Arial" pitchFamily="34" charset="-122"/>
                           <a:cs typeface="Arial" pitchFamily="34" charset="-120"/>
                         </a:rPr>
-                        <a:t>Transformer: tested, not assumed</a:t>
+                        <a:t>Leave-one-subject-out validation</a:t>
                       </a:r>
                       <a:endParaRPr lang="en-US" sz="1100" dirty="0">
                         <a:latin typeface="Arial" charset="0"/>
@@ -3639,7 +3630,7 @@
                           <a:ea typeface="Arial" pitchFamily="34" charset="-122"/>
                           <a:cs typeface="Arial" pitchFamily="34" charset="-120"/>
                         </a:rPr>
-                        <a:t>Promising but data-hungry and prone to false positives on sensor data</a:t>
+                        <a:t>“Evaluation is performed in a leave-one-subject-out (LOSO) fashion”</a:t>
                       </a:r>
                       <a:endParaRPr lang="en-US" sz="1100" dirty="0">
                         <a:latin typeface="Arial" charset="0"/>
@@ -3707,7 +3698,213 @@
                           <a:ea typeface="Arial" pitchFamily="34" charset="-122"/>
                           <a:cs typeface="Arial" pitchFamily="34" charset="-120"/>
                         </a:rPr>
-                        <a:t>Vedovelli et al. 2026; Ikram et al. 2025</a:t>
+                        <a:t>Diou et al. 2022, p. 5</a:t>
+                      </a:r>
+                      <a:endParaRPr lang="en-US" sz="1100" dirty="0">
+                        <a:latin typeface="Arial" charset="0"/>
+                        <a:ea typeface="Arial" charset="0"/>
+                        <a:cs typeface="Arial" charset="0"/>
+                      </a:endParaRPr>
+                    </a:p>
+                  </a:txBody>
+                  <a:tcPr marL="45720" marR="45720" marT="45720" marB="45720" anchor="ctr">
+                    <a:lnL w="9525" cap="flat" cmpd="sng" algn="ctr">
+                      <a:solidFill>
+                        <a:srgbClr val="BFBFBF"/>
+                      </a:solidFill>
+                      <a:prstDash val="solid"/>
+                      <a:round/>
+                      <a:headEnd type="none" w="med" len="med"/>
+                      <a:tailEnd type="none" w="med" len="med"/>
+                    </a:lnL>
+                    <a:lnR w="9525" cap="flat" cmpd="sng" algn="ctr">
+                      <a:solidFill>
+                        <a:srgbClr val="BFBFBF"/>
+                      </a:solidFill>
+                      <a:prstDash val="solid"/>
+                      <a:round/>
+                      <a:headEnd type="none" w="med" len="med"/>
+                      <a:tailEnd type="none" w="med" len="med"/>
+                    </a:lnR>
+                    <a:lnT w="9525" cap="flat" cmpd="sng" algn="ctr">
+                      <a:solidFill>
+                        <a:srgbClr val="BFBFBF"/>
+                      </a:solidFill>
+                      <a:prstDash val="solid"/>
+                      <a:round/>
+                      <a:headEnd type="none" w="med" len="med"/>
+                      <a:tailEnd type="none" w="med" len="med"/>
+                    </a:lnT>
+                    <a:lnB w="9525" cap="flat" cmpd="sng" algn="ctr">
+                      <a:solidFill>
+                        <a:srgbClr val="BFBFBF"/>
+                      </a:solidFill>
+                      <a:prstDash val="solid"/>
+                      <a:round/>
+                      <a:headEnd type="none" w="med" len="med"/>
+                      <a:tailEnd type="none" w="med" len="med"/>
+                    </a:lnB>
+                    <a:solidFill>
+                      <a:srgbClr val="FFFFFF"/>
+                    </a:solidFill>
+                  </a:tcPr>
+                </a:tc>
+              </a:tr>
+              <a:tr h="0">
+                <a:tc>
+                  <a:txBody>
+                    <a:bodyPr/>
+                    <a:lstStyle/>
+                    <a:p>
+                      <a:pPr algn="l" indent="0" marL="0">
+                        <a:buNone/>
+                      </a:pPr>
+                      <a:r>
+                        <a:rPr lang="en-US" sz="1100" dirty="0">
+                          <a:solidFill>
+                            <a:srgbClr val="222222"/>
+                          </a:solidFill>
+                          <a:latin typeface="Arial" pitchFamily="34" charset="0"/>
+                          <a:ea typeface="Arial" pitchFamily="34" charset="-122"/>
+                          <a:cs typeface="Arial" pitchFamily="34" charset="-120"/>
+                        </a:rPr>
+                        <a:t>Threshold chosen for the use case (false alarms)</a:t>
+                      </a:r>
+                      <a:endParaRPr lang="en-US" sz="1100" dirty="0">
+                        <a:latin typeface="Arial" charset="0"/>
+                        <a:ea typeface="Arial" charset="0"/>
+                        <a:cs typeface="Arial" charset="0"/>
+                      </a:endParaRPr>
+                    </a:p>
+                  </a:txBody>
+                  <a:tcPr marL="45720" marR="45720" marT="45720" marB="45720" anchor="ctr">
+                    <a:lnL w="9525" cap="flat" cmpd="sng" algn="ctr">
+                      <a:solidFill>
+                        <a:srgbClr val="BFBFBF"/>
+                      </a:solidFill>
+                      <a:prstDash val="solid"/>
+                      <a:round/>
+                      <a:headEnd type="none" w="med" len="med"/>
+                      <a:tailEnd type="none" w="med" len="med"/>
+                    </a:lnL>
+                    <a:lnR w="9525" cap="flat" cmpd="sng" algn="ctr">
+                      <a:solidFill>
+                        <a:srgbClr val="BFBFBF"/>
+                      </a:solidFill>
+                      <a:prstDash val="solid"/>
+                      <a:round/>
+                      <a:headEnd type="none" w="med" len="med"/>
+                      <a:tailEnd type="none" w="med" len="med"/>
+                    </a:lnR>
+                    <a:lnT w="9525" cap="flat" cmpd="sng" algn="ctr">
+                      <a:solidFill>
+                        <a:srgbClr val="BFBFBF"/>
+                      </a:solidFill>
+                      <a:prstDash val="solid"/>
+                      <a:round/>
+                      <a:headEnd type="none" w="med" len="med"/>
+                      <a:tailEnd type="none" w="med" len="med"/>
+                    </a:lnT>
+                    <a:lnB w="9525" cap="flat" cmpd="sng" algn="ctr">
+                      <a:solidFill>
+                        <a:srgbClr val="BFBFBF"/>
+                      </a:solidFill>
+                      <a:prstDash val="solid"/>
+                      <a:round/>
+                      <a:headEnd type="none" w="med" len="med"/>
+                      <a:tailEnd type="none" w="med" len="med"/>
+                    </a:lnB>
+                    <a:solidFill>
+                      <a:srgbClr val="FFFFFF"/>
+                    </a:solidFill>
+                  </a:tcPr>
+                </a:tc>
+                <a:tc>
+                  <a:txBody>
+                    <a:bodyPr/>
+                    <a:lstStyle/>
+                    <a:p>
+                      <a:pPr algn="l" indent="0" marL="0">
+                        <a:buNone/>
+                      </a:pPr>
+                      <a:r>
+                        <a:rPr lang="en-US" sz="1100" dirty="0">
+                          <a:solidFill>
+                            <a:srgbClr val="222222"/>
+                          </a:solidFill>
+                          <a:latin typeface="Arial" pitchFamily="34" charset="0"/>
+                          <a:ea typeface="Arial" pitchFamily="34" charset="-122"/>
+                          <a:cs typeface="Arial" pitchFamily="34" charset="-120"/>
+                        </a:rPr>
+                        <a:t>“allows the user to tune the detection system towards higher recall or precision, or a balanced mode, based on the needs of each use-case”</a:t>
+                      </a:r>
+                      <a:endParaRPr lang="en-US" sz="1100" dirty="0">
+                        <a:latin typeface="Arial" charset="0"/>
+                        <a:ea typeface="Arial" charset="0"/>
+                        <a:cs typeface="Arial" charset="0"/>
+                      </a:endParaRPr>
+                    </a:p>
+                  </a:txBody>
+                  <a:tcPr marL="45720" marR="45720" marT="45720" marB="45720" anchor="ctr">
+                    <a:lnL w="9525" cap="flat" cmpd="sng" algn="ctr">
+                      <a:solidFill>
+                        <a:srgbClr val="BFBFBF"/>
+                      </a:solidFill>
+                      <a:prstDash val="solid"/>
+                      <a:round/>
+                      <a:headEnd type="none" w="med" len="med"/>
+                      <a:tailEnd type="none" w="med" len="med"/>
+                    </a:lnL>
+                    <a:lnR w="9525" cap="flat" cmpd="sng" algn="ctr">
+                      <a:solidFill>
+                        <a:srgbClr val="BFBFBF"/>
+                      </a:solidFill>
+                      <a:prstDash val="solid"/>
+                      <a:round/>
+                      <a:headEnd type="none" w="med" len="med"/>
+                      <a:tailEnd type="none" w="med" len="med"/>
+                    </a:lnR>
+                    <a:lnT w="9525" cap="flat" cmpd="sng" algn="ctr">
+                      <a:solidFill>
+                        <a:srgbClr val="BFBFBF"/>
+                      </a:solidFill>
+                      <a:prstDash val="solid"/>
+                      <a:round/>
+                      <a:headEnd type="none" w="med" len="med"/>
+                      <a:tailEnd type="none" w="med" len="med"/>
+                    </a:lnT>
+                    <a:lnB w="9525" cap="flat" cmpd="sng" algn="ctr">
+                      <a:solidFill>
+                        <a:srgbClr val="BFBFBF"/>
+                      </a:solidFill>
+                      <a:prstDash val="solid"/>
+                      <a:round/>
+                      <a:headEnd type="none" w="med" len="med"/>
+                      <a:tailEnd type="none" w="med" len="med"/>
+                    </a:lnB>
+                    <a:solidFill>
+                      <a:srgbClr val="FFFFFF"/>
+                    </a:solidFill>
+                  </a:tcPr>
+                </a:tc>
+                <a:tc>
+                  <a:txBody>
+                    <a:bodyPr/>
+                    <a:lstStyle/>
+                    <a:p>
+                      <a:pPr algn="l" indent="0" marL="0">
+                        <a:buNone/>
+                      </a:pPr>
+                      <a:r>
+                        <a:rPr lang="en-US" sz="1100" dirty="0">
+                          <a:solidFill>
+                            <a:srgbClr val="222222"/>
+                          </a:solidFill>
+                          <a:latin typeface="Arial" pitchFamily="34" charset="0"/>
+                          <a:ea typeface="Arial" pitchFamily="34" charset="-122"/>
+                          <a:cs typeface="Arial" pitchFamily="34" charset="-120"/>
+                        </a:rPr>
+                        <a:t>Diou et al. 2022, p. 8</a:t>
                       </a:r>
                       <a:endParaRPr lang="en-US" sz="1100" dirty="0">
                         <a:latin typeface="Arial" charset="0"/>

</xml_diff>

<commit_message>
Map model components to the ten reviewed papers only
The literature slide now draws its evidence from the papers on the
literature-review slides, and marks the chew-count head and the
time-series-versus-FFT comparison as this project's own contributions.

Co-Authored-By: Claude Opus 5.5 <noreply@anthropic.com>
Claude-Session: https://claude.ai/code/session_017rMsJrfJb6LTfE8bFvgHeu
</commit_message>
<xml_diff>
--- a/docs/presentation/lab_meeting_new_slides.pptx
+++ b/docs/presentation/lab_meeting_new_slides.pptx
@@ -1258,9 +1258,7 @@
           <a:p>
             <a:r>
               <a:rPr lang="en-US" dirty="0"/>
-              <a:t>Every row is a direct quote, with its page. Wang, Yan &amp; Oates 2017 is the standard reference for classifying time series with convolutional networks straight from the raw signal: their FCN is three conv + batch-norm + ReLU blocks, and z-normalisation is their only preprocessing, which is exactly our trunk and our normalisation. They compare against COTE, an ensemble built on features from both the time and frequency domains, and match or beat it from raw data. Diou et al. 2022 is the Thessaloniki group's review of their intake-monitoring work: the end-to-end model on raw smartwatch data beat every hand-engineered method, everything is evaluated leave-one-subject-out, and they report that walking at 1-3 Hz looks like chewing and causes false positives. That is the argument for keeping the accelerometer next to the optical sensor, and for choosing the threshold for the use case.
-Important: neither paper compares time series against an FFT on the same model. That comparison is our own result (next slides): F1 0.858 vs 0.796, false alarms 81 -&gt; 32 per hour.
-Still to quote from the primary papers (need the PDFs): squeeze-and-excitation (Hu et al. 2018), attention pooling (Ilse et al. 2018), the auxiliary chew head (Caruana 1997), and subject-wise versus record-wise validation (Saeb et al. 2017).</a:t>
+              <a:t>Everything here comes from the papers on the previous two slides. Ghosh &amp; Sazonov ran deep networks directly on AIM-2 signals, the same sensor we use, and Kyritsis showed end-to-end learning beating hand-engineered features. Diou's review is the reason both sensors stay in: walking at 1-3 Hz looks like chewing and causes false positives. On Transformers the evidence is mixed: Wang 2024 made attention work on 61 people, Vedovelli's Transformer had poor specificity, and the 97% ECG result was not split by patient. So I use light attention by default and test a Transformer as an option. Two pieces are ours, and I say so: the chew-count head, and the time-series-versus-FFT comparison, which is our own experimental result.</a:t>
             </a:r>
             <a:endParaRPr lang="en-US" dirty="0"/>
           </a:p>
@@ -2304,9 +2302,9 @@
             <a:tbl>
               <a:tblPr/>
               <a:tblGrid>
-                <a:gridCol w="2148840"/>
-                <a:gridCol w="4343400"/>
-                <a:gridCol w="1737360"/>
+                <a:gridCol w="2377440"/>
+                <a:gridCol w="3840480"/>
+                <a:gridCol w="2011680"/>
               </a:tblGrid>
               <a:tr h="0">
                 <a:tc>
@@ -2394,7 +2392,7 @@
                           <a:ea typeface="Arial" pitchFamily="34" charset="-122"/>
                           <a:cs typeface="Arial" pitchFamily="34" charset="-120"/>
                         </a:rPr>
-                        <a:t>Published statement</a:t>
+                        <a:t>What the reviewed papers found</a:t>
                       </a:r>
                       <a:endParaRPr lang="en-US" sz="1100" dirty="0">
                         <a:latin typeface="Arial" charset="0"/>
@@ -2462,7 +2460,7 @@
                           <a:ea typeface="Arial" pitchFamily="34" charset="-122"/>
                           <a:cs typeface="Arial" pitchFamily="34" charset="-120"/>
                         </a:rPr>
-                        <a:t>Source</a:t>
+                        <a:t>Papers</a:t>
                       </a:r>
                       <a:endParaRPr lang="en-US" sz="1100" dirty="0">
                         <a:latin typeface="Arial" charset="0"/>
@@ -2532,7 +2530,7 @@
                           <a:ea typeface="Arial" pitchFamily="34" charset="-122"/>
                           <a:cs typeface="Arial" pitchFamily="34" charset="-120"/>
                         </a:rPr>
-                        <a:t>Raw time-series input, no FFT or hand-crafted features</a:t>
+                        <a:t>Learned features from the normalised time series, not hand-crafted features</a:t>
                       </a:r>
                       <a:endParaRPr lang="en-US" sz="1100" dirty="0">
                         <a:latin typeface="Arial" charset="0"/>
@@ -2600,7 +2598,7 @@
                           <a:ea typeface="Arial" pitchFamily="34" charset="-122"/>
                           <a:cs typeface="Arial" pitchFamily="34" charset="-120"/>
                         </a:rPr>
-                        <a:t>“Our proposed baseline models are pure end-to-end without any heavy preprocessing on the raw data or feature crafting.”</a:t>
+                        <a:t>Deep nets on AIM-2 optical + accelerometer signals reached 93.5% balanced accuracy; end-to-end learning on raw IMU beat hand-engineered methods (bite F1 0.923)</a:t>
                       </a:r>
                       <a:endParaRPr lang="en-US" sz="1100" dirty="0">
                         <a:latin typeface="Arial" charset="0"/>
@@ -2668,7 +2666,7 @@
                           <a:ea typeface="Arial" pitchFamily="34" charset="-122"/>
                           <a:cs typeface="Arial" pitchFamily="34" charset="-120"/>
                         </a:rPr>
-                        <a:t>Wang et al. 2017, p. 1</a:t>
+                        <a:t>Ghosh &amp; Sazonov 2022; Kyritsis et al. 2021; Doulah et al. 2021</a:t>
                       </a:r>
                       <a:endParaRPr lang="en-US" sz="1100" dirty="0">
                         <a:latin typeface="Arial" charset="0"/>
@@ -2738,7 +2736,7 @@
                           <a:ea typeface="Arial" pitchFamily="34" charset="-122"/>
                           <a:cs typeface="Arial" pitchFamily="34" charset="-120"/>
                         </a:rPr>
-                        <a:t>Raw input for eating detection</a:t>
+                        <a:t>Optical and accelerometer together, weighted per window (channel attention)</a:t>
                       </a:r>
                       <a:endParaRPr lang="en-US" sz="1100" dirty="0">
                         <a:latin typeface="Arial" charset="0"/>
@@ -2806,7 +2804,7 @@
                           <a:ea typeface="Arial" pitchFamily="34" charset="-122"/>
                           <a:cs typeface="Arial" pitchFamily="34" charset="-120"/>
                         </a:rPr>
-                        <a:t>“processes the raw inertial data (not using hand-engineered features)”; this end-to-end approach “outperforms all other methods”</a:t>
+                        <a:t>Walking at 1–3 Hz looks like chewing and causes false positives; motion signals are needed to reject it</a:t>
                       </a:r>
                       <a:endParaRPr lang="en-US" sz="1100" dirty="0">
                         <a:latin typeface="Arial" charset="0"/>
@@ -2874,7 +2872,7 @@
                           <a:ea typeface="Arial" pitchFamily="34" charset="-122"/>
                           <a:cs typeface="Arial" pitchFamily="34" charset="-120"/>
                         </a:rPr>
-                        <a:t>Diou et al. 2022, pp. 4–5</a:t>
+                        <a:t>Diou et al. 2022; Doulah et al. 2021</a:t>
                       </a:r>
                       <a:endParaRPr lang="en-US" sz="1100" dirty="0">
                         <a:latin typeface="Arial" charset="0"/>
@@ -2944,7 +2942,7 @@
                           <a:ea typeface="Arial" pitchFamily="34" charset="-122"/>
                           <a:cs typeface="Arial" pitchFamily="34" charset="-120"/>
                         </a:rPr>
-                        <a:t>Per-window z-score normalisation</a:t>
+                        <a:t>Light attention on a CNN, Transformer tested as an option</a:t>
                       </a:r>
                       <a:endParaRPr lang="en-US" sz="1100" dirty="0">
                         <a:latin typeface="Arial" charset="0"/>
@@ -3012,7 +3010,7 @@
                           <a:ea typeface="Arial" pitchFamily="34" charset="-122"/>
                           <a:cs typeface="Arial" pitchFamily="34" charset="-120"/>
                         </a:rPr>
-                        <a:t>“The only preprocessing in our experiment is z-normalization”</a:t>
+                        <a:t>CNN + self-attention works on 61 people; a Transformer had specificity of only 0.50; Transformer ECG results used beat-level splits</a:t>
                       </a:r>
                       <a:endParaRPr lang="en-US" sz="1100" dirty="0">
                         <a:latin typeface="Arial" charset="0"/>
@@ -3080,7 +3078,7 @@
                           <a:ea typeface="Arial" pitchFamily="34" charset="-122"/>
                           <a:cs typeface="Arial" pitchFamily="34" charset="-120"/>
                         </a:rPr>
-                        <a:t>Wang et al. 2017, p. 3</a:t>
+                        <a:t>Wang et al. 2024; Vedovelli et al. 2026; Ikram et al. 2025</a:t>
                       </a:r>
                       <a:endParaRPr lang="en-US" sz="1100" dirty="0">
                         <a:latin typeface="Arial" charset="0"/>
@@ -3150,7 +3148,7 @@
                           <a:ea typeface="Arial" pitchFamily="34" charset="-122"/>
                           <a:cs typeface="Arial" pitchFamily="34" charset="-120"/>
                         </a:rPr>
-                        <a:t>Conv + batch norm + ReLU blocks</a:t>
+                        <a:t>Participant-level (leave-one-out) validation</a:t>
                       </a:r>
                       <a:endParaRPr lang="en-US" sz="1100" dirty="0">
                         <a:latin typeface="Arial" charset="0"/>
@@ -3218,7 +3216,7 @@
                           <a:ea typeface="Arial" pitchFamily="34" charset="-122"/>
                           <a:cs typeface="Arial" pitchFamily="34" charset="-120"/>
                         </a:rPr>
-                        <a:t>“The basic block is a convolutional layer followed by a batch normalization layer [...] and a ReLU activation layer.”</a:t>
+                        <a:t>AIM-2, smartwatch bite and Transformer eating studies all test on held-out people; the 97% ECG result did not split by patient</a:t>
                       </a:r>
                       <a:endParaRPr lang="en-US" sz="1100" dirty="0">
                         <a:latin typeface="Arial" charset="0"/>
@@ -3286,7 +3284,7 @@
                           <a:ea typeface="Arial" pitchFamily="34" charset="-122"/>
                           <a:cs typeface="Arial" pitchFamily="34" charset="-120"/>
                         </a:rPr>
-                        <a:t>Wang et al. 2017, p. 2</a:t>
+                        <a:t>Doulah et al. 2021; Kyritsis et al. 2021; Vedovelli et al. 2026; Ikram et al. 2025</a:t>
                       </a:r>
                       <a:endParaRPr lang="en-US" sz="1100" dirty="0">
                         <a:latin typeface="Arial" charset="0"/>
@@ -3356,7 +3354,7 @@
                           <a:ea typeface="Arial" pitchFamily="34" charset="-122"/>
                           <a:cs typeface="Arial" pitchFamily="34" charset="-120"/>
                         </a:rPr>
-                        <a:t>Accelerometer alongside optical, weighted by channel attention</a:t>
+                        <a:t>Operating point and negatives aimed at false positives</a:t>
                       </a:r>
                       <a:endParaRPr lang="en-US" sz="1100" dirty="0">
                         <a:latin typeface="Arial" charset="0"/>
@@ -3424,7 +3422,7 @@
                           <a:ea typeface="Arial" pitchFamily="34" charset="-122"/>
                           <a:cs typeface="Arial" pitchFamily="34" charset="-120"/>
                         </a:rPr>
-                        <a:t>“walking rhythm is similar to chewing (i.e. 1 to 3 Hz) [...] causing the classification models to yield high false-positive detections”</a:t>
+                        <a:t>Hard negative examples and sensor-image fusion both reduced false positives</a:t>
                       </a:r>
                       <a:endParaRPr lang="en-US" sz="1100" dirty="0">
                         <a:latin typeface="Arial" charset="0"/>
@@ -3492,7 +3490,7 @@
                           <a:ea typeface="Arial" pitchFamily="34" charset="-122"/>
                           <a:cs typeface="Arial" pitchFamily="34" charset="-120"/>
                         </a:rPr>
-                        <a:t>Diou et al. 2022, p. 8</a:t>
+                        <a:t>Stankoski et al. 2021; Ghosh et al. 2024</a:t>
                       </a:r>
                       <a:endParaRPr lang="en-US" sz="1100" dirty="0">
                         <a:latin typeface="Arial" charset="0"/>
@@ -3562,7 +3560,7 @@
                           <a:ea typeface="Arial" pitchFamily="34" charset="-122"/>
                           <a:cs typeface="Arial" pitchFamily="34" charset="-120"/>
                         </a:rPr>
-                        <a:t>Leave-one-subject-out validation</a:t>
+                        <a:t>Chew-count head; time series vs FFT</a:t>
                       </a:r>
                       <a:endParaRPr lang="en-US" sz="1100" dirty="0">
                         <a:latin typeface="Arial" charset="0"/>
@@ -3630,7 +3628,7 @@
                           <a:ea typeface="Arial" pitchFamily="34" charset="-122"/>
                           <a:cs typeface="Arial" pitchFamily="34" charset="-120"/>
                         </a:rPr>
-                        <a:t>“Evaluation is performed in a leave-one-subject-out (LOSO) fashion”</a:t>
+                        <a:t>Our additions: few labels motivate extra supervision; the FFT comparison is our own result (F1 0.858 vs 0.796)</a:t>
                       </a:r>
                       <a:endParaRPr lang="en-US" sz="1100" dirty="0">
                         <a:latin typeface="Arial" charset="0"/>
@@ -3698,213 +3696,7 @@
                           <a:ea typeface="Arial" pitchFamily="34" charset="-122"/>
                           <a:cs typeface="Arial" pitchFamily="34" charset="-120"/>
                         </a:rPr>
-                        <a:t>Diou et al. 2022, p. 5</a:t>
-                      </a:r>
-                      <a:endParaRPr lang="en-US" sz="1100" dirty="0">
-                        <a:latin typeface="Arial" charset="0"/>
-                        <a:ea typeface="Arial" charset="0"/>
-                        <a:cs typeface="Arial" charset="0"/>
-                      </a:endParaRPr>
-                    </a:p>
-                  </a:txBody>
-                  <a:tcPr marL="45720" marR="45720" marT="45720" marB="45720" anchor="ctr">
-                    <a:lnL w="9525" cap="flat" cmpd="sng" algn="ctr">
-                      <a:solidFill>
-                        <a:srgbClr val="BFBFBF"/>
-                      </a:solidFill>
-                      <a:prstDash val="solid"/>
-                      <a:round/>
-                      <a:headEnd type="none" w="med" len="med"/>
-                      <a:tailEnd type="none" w="med" len="med"/>
-                    </a:lnL>
-                    <a:lnR w="9525" cap="flat" cmpd="sng" algn="ctr">
-                      <a:solidFill>
-                        <a:srgbClr val="BFBFBF"/>
-                      </a:solidFill>
-                      <a:prstDash val="solid"/>
-                      <a:round/>
-                      <a:headEnd type="none" w="med" len="med"/>
-                      <a:tailEnd type="none" w="med" len="med"/>
-                    </a:lnR>
-                    <a:lnT w="9525" cap="flat" cmpd="sng" algn="ctr">
-                      <a:solidFill>
-                        <a:srgbClr val="BFBFBF"/>
-                      </a:solidFill>
-                      <a:prstDash val="solid"/>
-                      <a:round/>
-                      <a:headEnd type="none" w="med" len="med"/>
-                      <a:tailEnd type="none" w="med" len="med"/>
-                    </a:lnT>
-                    <a:lnB w="9525" cap="flat" cmpd="sng" algn="ctr">
-                      <a:solidFill>
-                        <a:srgbClr val="BFBFBF"/>
-                      </a:solidFill>
-                      <a:prstDash val="solid"/>
-                      <a:round/>
-                      <a:headEnd type="none" w="med" len="med"/>
-                      <a:tailEnd type="none" w="med" len="med"/>
-                    </a:lnB>
-                    <a:solidFill>
-                      <a:srgbClr val="FFFFFF"/>
-                    </a:solidFill>
-                  </a:tcPr>
-                </a:tc>
-              </a:tr>
-              <a:tr h="0">
-                <a:tc>
-                  <a:txBody>
-                    <a:bodyPr/>
-                    <a:lstStyle/>
-                    <a:p>
-                      <a:pPr algn="l" indent="0" marL="0">
-                        <a:buNone/>
-                      </a:pPr>
-                      <a:r>
-                        <a:rPr lang="en-US" sz="1100" dirty="0">
-                          <a:solidFill>
-                            <a:srgbClr val="222222"/>
-                          </a:solidFill>
-                          <a:latin typeface="Arial" pitchFamily="34" charset="0"/>
-                          <a:ea typeface="Arial" pitchFamily="34" charset="-122"/>
-                          <a:cs typeface="Arial" pitchFamily="34" charset="-120"/>
-                        </a:rPr>
-                        <a:t>Threshold chosen for the use case (false alarms)</a:t>
-                      </a:r>
-                      <a:endParaRPr lang="en-US" sz="1100" dirty="0">
-                        <a:latin typeface="Arial" charset="0"/>
-                        <a:ea typeface="Arial" charset="0"/>
-                        <a:cs typeface="Arial" charset="0"/>
-                      </a:endParaRPr>
-                    </a:p>
-                  </a:txBody>
-                  <a:tcPr marL="45720" marR="45720" marT="45720" marB="45720" anchor="ctr">
-                    <a:lnL w="9525" cap="flat" cmpd="sng" algn="ctr">
-                      <a:solidFill>
-                        <a:srgbClr val="BFBFBF"/>
-                      </a:solidFill>
-                      <a:prstDash val="solid"/>
-                      <a:round/>
-                      <a:headEnd type="none" w="med" len="med"/>
-                      <a:tailEnd type="none" w="med" len="med"/>
-                    </a:lnL>
-                    <a:lnR w="9525" cap="flat" cmpd="sng" algn="ctr">
-                      <a:solidFill>
-                        <a:srgbClr val="BFBFBF"/>
-                      </a:solidFill>
-                      <a:prstDash val="solid"/>
-                      <a:round/>
-                      <a:headEnd type="none" w="med" len="med"/>
-                      <a:tailEnd type="none" w="med" len="med"/>
-                    </a:lnR>
-                    <a:lnT w="9525" cap="flat" cmpd="sng" algn="ctr">
-                      <a:solidFill>
-                        <a:srgbClr val="BFBFBF"/>
-                      </a:solidFill>
-                      <a:prstDash val="solid"/>
-                      <a:round/>
-                      <a:headEnd type="none" w="med" len="med"/>
-                      <a:tailEnd type="none" w="med" len="med"/>
-                    </a:lnT>
-                    <a:lnB w="9525" cap="flat" cmpd="sng" algn="ctr">
-                      <a:solidFill>
-                        <a:srgbClr val="BFBFBF"/>
-                      </a:solidFill>
-                      <a:prstDash val="solid"/>
-                      <a:round/>
-                      <a:headEnd type="none" w="med" len="med"/>
-                      <a:tailEnd type="none" w="med" len="med"/>
-                    </a:lnB>
-                    <a:solidFill>
-                      <a:srgbClr val="FFFFFF"/>
-                    </a:solidFill>
-                  </a:tcPr>
-                </a:tc>
-                <a:tc>
-                  <a:txBody>
-                    <a:bodyPr/>
-                    <a:lstStyle/>
-                    <a:p>
-                      <a:pPr algn="l" indent="0" marL="0">
-                        <a:buNone/>
-                      </a:pPr>
-                      <a:r>
-                        <a:rPr lang="en-US" sz="1100" dirty="0">
-                          <a:solidFill>
-                            <a:srgbClr val="222222"/>
-                          </a:solidFill>
-                          <a:latin typeface="Arial" pitchFamily="34" charset="0"/>
-                          <a:ea typeface="Arial" pitchFamily="34" charset="-122"/>
-                          <a:cs typeface="Arial" pitchFamily="34" charset="-120"/>
-                        </a:rPr>
-                        <a:t>“allows the user to tune the detection system towards higher recall or precision, or a balanced mode, based on the needs of each use-case”</a:t>
-                      </a:r>
-                      <a:endParaRPr lang="en-US" sz="1100" dirty="0">
-                        <a:latin typeface="Arial" charset="0"/>
-                        <a:ea typeface="Arial" charset="0"/>
-                        <a:cs typeface="Arial" charset="0"/>
-                      </a:endParaRPr>
-                    </a:p>
-                  </a:txBody>
-                  <a:tcPr marL="45720" marR="45720" marT="45720" marB="45720" anchor="ctr">
-                    <a:lnL w="9525" cap="flat" cmpd="sng" algn="ctr">
-                      <a:solidFill>
-                        <a:srgbClr val="BFBFBF"/>
-                      </a:solidFill>
-                      <a:prstDash val="solid"/>
-                      <a:round/>
-                      <a:headEnd type="none" w="med" len="med"/>
-                      <a:tailEnd type="none" w="med" len="med"/>
-                    </a:lnL>
-                    <a:lnR w="9525" cap="flat" cmpd="sng" algn="ctr">
-                      <a:solidFill>
-                        <a:srgbClr val="BFBFBF"/>
-                      </a:solidFill>
-                      <a:prstDash val="solid"/>
-                      <a:round/>
-                      <a:headEnd type="none" w="med" len="med"/>
-                      <a:tailEnd type="none" w="med" len="med"/>
-                    </a:lnR>
-                    <a:lnT w="9525" cap="flat" cmpd="sng" algn="ctr">
-                      <a:solidFill>
-                        <a:srgbClr val="BFBFBF"/>
-                      </a:solidFill>
-                      <a:prstDash val="solid"/>
-                      <a:round/>
-                      <a:headEnd type="none" w="med" len="med"/>
-                      <a:tailEnd type="none" w="med" len="med"/>
-                    </a:lnT>
-                    <a:lnB w="9525" cap="flat" cmpd="sng" algn="ctr">
-                      <a:solidFill>
-                        <a:srgbClr val="BFBFBF"/>
-                      </a:solidFill>
-                      <a:prstDash val="solid"/>
-                      <a:round/>
-                      <a:headEnd type="none" w="med" len="med"/>
-                      <a:tailEnd type="none" w="med" len="med"/>
-                    </a:lnB>
-                    <a:solidFill>
-                      <a:srgbClr val="FFFFFF"/>
-                    </a:solidFill>
-                  </a:tcPr>
-                </a:tc>
-                <a:tc>
-                  <a:txBody>
-                    <a:bodyPr/>
-                    <a:lstStyle/>
-                    <a:p>
-                      <a:pPr algn="l" indent="0" marL="0">
-                        <a:buNone/>
-                      </a:pPr>
-                      <a:r>
-                        <a:rPr lang="en-US" sz="1100" dirty="0">
-                          <a:solidFill>
-                            <a:srgbClr val="222222"/>
-                          </a:solidFill>
-                          <a:latin typeface="Arial" pitchFamily="34" charset="0"/>
-                          <a:ea typeface="Arial" pitchFamily="34" charset="-122"/>
-                          <a:cs typeface="Arial" pitchFamily="34" charset="-120"/>
-                        </a:rPr>
-                        <a:t>Diou et al. 2022, p. 8</a:t>
+                        <a:t>This work (motivated by Diou et al. 2022)</a:t>
                       </a:r>
                       <a:endParaRPr lang="en-US" sz="1100" dirty="0">
                         <a:latin typeface="Arial" charset="0"/>

</xml_diff>

<commit_message>
Reword the attention row: the Transformer is implemented, not yet tested
Co-Authored-By: Claude Opus 5.5 <noreply@anthropic.com>
Claude-Session: https://claude.ai/code/session_017rMsJrfJb6LTfE8bFvgHeu
</commit_message>
<xml_diff>
--- a/docs/presentation/lab_meeting_new_slides.pptx
+++ b/docs/presentation/lab_meeting_new_slides.pptx
@@ -1258,7 +1258,7 @@
           <a:p>
             <a:r>
               <a:rPr lang="en-US" dirty="0"/>
-              <a:t>Everything here comes from the papers on the previous two slides. Ghosh &amp; Sazonov ran deep networks directly on AIM-2 signals, the same sensor we use, and Kyritsis showed end-to-end learning beating hand-engineered features. Diou's review is the reason both sensors stay in: walking at 1-3 Hz looks like chewing and causes false positives. On Transformers the evidence is mixed: Wang 2024 made attention work on 61 people, Vedovelli's Transformer had poor specificity, and the 97% ECG result was not split by patient. So I use light attention by default and test a Transformer as an option. Two pieces are ours, and I say so: the chew-count head, and the time-series-versus-FFT comparison, which is our own experimental result.</a:t>
+              <a:t>Everything here comes from the papers on the previous two slides. Ghosh &amp; Sazonov ran deep networks directly on AIM-2 signals, the same sensor we use, and Kyritsis showed end-to-end learning beating hand-engineered features. Diou's review is the reason both sensors stay in: walking at 1-3 Hz looks like chewing and causes false positives. On Transformers the evidence is mixed: Wang 2024 made attention work on 61 people, Vedovelli's Transformer had poor specificity, and the 97% ECG result was not split by patient. So I use light attention on a CNN; a Transformer is built in and will be run on the full dataset. Two pieces are ours, and I say so: the chew-count head, and the time-series-versus-FFT comparison, which is our own experimental result.</a:t>
             </a:r>
             <a:endParaRPr lang="en-US" dirty="0"/>
           </a:p>
@@ -2942,7 +2942,7 @@
                           <a:ea typeface="Arial" pitchFamily="34" charset="-122"/>
                           <a:cs typeface="Arial" pitchFamily="34" charset="-120"/>
                         </a:rPr>
-                        <a:t>Light attention on a CNN, Transformer tested as an option</a:t>
+                        <a:t>Light attention on a CNN, not a full Transformer</a:t>
                       </a:r>
                       <a:endParaRPr lang="en-US" sz="1100" dirty="0">
                         <a:latin typeface="Arial" charset="0"/>

</xml_diff>